<commit_message>
Opções denunciadoras: a certa deixa de ser «quase de certeza» a mais comprida (#139)
363 denunciadoras resolvidas em 196 ficheiros (425 trocas literais, com retorno por opção); catraca por pasta para a amplitude e a certa mais longa; diapositivos do M1 e do M4 só nas perguntas mudadas.

Co-Authored-By: Claude Opus 5.5 <noreply@anthropic.com>
Claude-Session: https://claude.ai/code/session_019kk5YG7rVg4NAnh75qeMqa
</commit_message>
<xml_diff>
--- a/m1/diapositivos/aula-05-f19.pptx
+++ b/m1/diapositivos/aula-05-f19.pptx
@@ -4752,7 +4752,7 @@
                 <a:ea typeface="Arial" pitchFamily="34" charset="-122"/>
                 <a:cs typeface="Arial" pitchFamily="34" charset="-120"/>
               </a:rPr>
-              <a:t>Em Mendinho ameaça e cerca; em Codax ouve a pergunta, como confidente</a:t>
+              <a:t>Em Mendinho cerca; em Codax ouve, como confidente</a:t>
             </a:r>
             <a:endParaRPr lang="en-US" sz="3400" dirty="0"/>
           </a:p>
@@ -18007,7 +18007,7 @@
                 <a:ea typeface="Arial" pitchFamily="34" charset="-122"/>
                 <a:cs typeface="Arial" pitchFamily="34" charset="-120"/>
               </a:rPr>
-              <a:t>Nas duas, o mar é só paisagem</a:t>
+              <a:t>Nas duas, o mar é só paisagem, sem papel na cena</a:t>
             </a:r>
             <a:endParaRPr lang="en-US" sz="2400" dirty="0"/>
           </a:p>
@@ -18115,7 +18115,7 @@
                 <a:ea typeface="Arial" pitchFamily="34" charset="-122"/>
                 <a:cs typeface="Arial" pitchFamily="34" charset="-120"/>
               </a:rPr>
-              <a:t>Em Codax ameaça; em Mendinho ouve e consola</a:t>
+              <a:t>Em Codax ameaça e cerca; em Mendinho ouve e consola</a:t>
             </a:r>
             <a:endParaRPr lang="en-US" sz="2400" dirty="0"/>
           </a:p>
@@ -18194,7 +18194,7 @@
         <p:spPr>
           <a:xfrm>
             <a:off x="1417320" y="4501896"/>
-            <a:ext cx="9174175" cy="981456"/>
+            <a:ext cx="9174175" cy="600456"/>
           </a:xfrm>
           <a:prstGeom prst="rect">
             <a:avLst/>
@@ -18223,7 +18223,7 @@
                 <a:ea typeface="Arial" pitchFamily="34" charset="-122"/>
                 <a:cs typeface="Arial" pitchFamily="34" charset="-120"/>
               </a:rPr>
-              <a:t>Em Mendinho ameaça e cerca; em Codax ouve a pergunta, como confidente</a:t>
+              <a:t>Em Mendinho cerca; em Codax ouve, como confidente</a:t>
             </a:r>
             <a:endParaRPr lang="en-US" sz="2400" dirty="0"/>
           </a:p>

</xml_diff>